<commit_message>
Month-end for every month, deliberate period locks, Calls downloads from templates
- Period-lock register (Data/Common/period_lock.csv, tools/lock_period.py): a month is Locked only when
  someone locks it; reports and the home dashboard default to the most recent locked month. Statuses show
  the reported month only.
- month_end.py: balance sheet and cash flow for every month end, Oct 2024 to Sep 2026, joining the locked
  model at 31 Jul 2026 to the dollar (fact_balance_month, fact_cash_flow_month). Home dashboard shows all
  three statements for every month. History fixes: services milestone billing, finished grants' instalments,
  no duplicate May-Jul services invoices. P&L unchanged.
- Calls report: Excel, PDF and PowerPoint made on click from templates (assets/exports/), no pre-built files.

Co-Authored-By: Claude Opus 5.5 <noreply@anthropic.com>
</commit_message>
<xml_diff>
--- a/media/exports/deliveries-sample.pptx
+++ b/media/exports/deliveries-sample.pptx
@@ -4249,7 +4249,7 @@
                 </a:solidFill>
                 <a:latin typeface="Roboto"/>
               </a:rPr>
-              <a:t>1-5 October: provisional (October locks 3 Nov).</a:t>
+              <a:t>1-5 October: provisional (until October is locked).</a:t>
             </a:r>
           </a:p>
           <a:p>
@@ -4343,7 +4343,7 @@
                 </a:solidFill>
                 <a:latin typeface="Roboto"/>
               </a:rPr>
-              <a:t>Data retrieved 2pm, Tue 6 Oct 2026 · Generated 9 Oct 2026, 8:39am · Sample data · Made with Python (python-pptx)</a:t>
+              <a:t>Data retrieved 2pm, Tue 6 Oct 2026 · Generated 22 Oct 2026, 7:51pm · Sample data · Made with Python (python-pptx)</a:t>
             </a:r>
           </a:p>
         </p:txBody>
@@ -5431,7 +5431,7 @@
                 </a:solidFill>
                 <a:latin typeface="Roboto"/>
               </a:rPr>
-              <a:t>Data retrieved 2pm, Tue 6 Oct 2026 · Generated 9 Oct 2026, 8:39am · Sample data · Made with Python (python-pptx)</a:t>
+              <a:t>Data retrieved 2pm, Tue 6 Oct 2026 · Generated 22 Oct 2026, 7:51pm · Sample data · Made with Python (python-pptx)</a:t>
             </a:r>
           </a:p>
         </p:txBody>
@@ -5752,7 +5752,7 @@
                 </a:solidFill>
                 <a:latin typeface="Roboto"/>
               </a:rPr>
-              <a:t>Data retrieved 2pm, Tue 6 Oct 2026 · Generated 9 Oct 2026, 8:39am · Sample data · Made with Python (python-pptx)</a:t>
+              <a:t>Data retrieved 2pm, Tue 6 Oct 2026 · Generated 22 Oct 2026, 7:51pm · Sample data · Made with Python (python-pptx)</a:t>
             </a:r>
           </a:p>
         </p:txBody>
@@ -6469,7 +6469,7 @@
                 </a:solidFill>
                 <a:latin typeface="Roboto"/>
               </a:rPr>
-              <a:t>Data retrieved 2pm, Tue 6 Oct 2026 · Generated 9 Oct 2026, 8:39am · Sample data · Made with Python (python-pptx)</a:t>
+              <a:t>Data retrieved 2pm, Tue 6 Oct 2026 · Generated 22 Oct 2026, 7:51pm · Sample data · Made with Python (python-pptx)</a:t>
             </a:r>
           </a:p>
         </p:txBody>
@@ -7557,7 +7557,7 @@
                 </a:solidFill>
                 <a:latin typeface="Roboto"/>
               </a:rPr>
-              <a:t>Data retrieved 2pm, Tue 6 Oct 2026 · Generated 9 Oct 2026, 8:39am · Sample data · Made with Python (python-pptx)</a:t>
+              <a:t>Data retrieved 2pm, Tue 6 Oct 2026 · Generated 22 Oct 2026, 7:51pm · Sample data · Made with Python (python-pptx)</a:t>
             </a:r>
           </a:p>
         </p:txBody>
@@ -7878,7 +7878,7 @@
                 </a:solidFill>
                 <a:latin typeface="Roboto"/>
               </a:rPr>
-              <a:t>Data retrieved 2pm, Tue 6 Oct 2026 · Generated 9 Oct 2026, 8:39am · Sample data · Made with Python (python-pptx)</a:t>
+              <a:t>Data retrieved 2pm, Tue 6 Oct 2026 · Generated 22 Oct 2026, 7:51pm · Sample data · Made with Python (python-pptx)</a:t>
             </a:r>
           </a:p>
         </p:txBody>
@@ -8595,7 +8595,7 @@
                 </a:solidFill>
                 <a:latin typeface="Roboto"/>
               </a:rPr>
-              <a:t>Data retrieved 2pm, Tue 6 Oct 2026 · Generated 9 Oct 2026, 8:39am · Sample data · Made with Python (python-pptx)</a:t>
+              <a:t>Data retrieved 2pm, Tue 6 Oct 2026 · Generated 22 Oct 2026, 7:51pm · Sample data · Made with Python (python-pptx)</a:t>
             </a:r>
           </a:p>
         </p:txBody>

</xml_diff>

<commit_message>
New mark in the downloads and the share image
- PDF headers (reports, deliveries, monthly report pack) draw the "4th"
  sheet (exportkit.MARK_SVG); slide decks' title slide uses mark-4th-180.png
- All PDFs and slide decks rebuilt (spreadsheets unchanged); every
  download still matches the site (exports_match: all 4 checks pass)
- og-image.png redrawn with the new mark, near-white background and a
  sentence-case eyebrow
- exportkit: generated.json keys use forward slashes on every OS, so a
  build on Windows keeps the stamps of files whose content didn't change

Co-Authored-By: Claude Opus 5.5 <noreply@anthropic.com>
</commit_message>
<xml_diff>
--- a/media/exports/deliveries-sample.pptx
+++ b/media/exports/deliveries-sample.pptx
@@ -3971,62 +3971,30 @@
           </a:p>
         </p:txBody>
       </p:sp>
-      <p:sp>
-        <p:nvSpPr>
-          <p:cNvPr id="3" name="Rectangle 2"/>
-          <p:cNvSpPr/>
+      <p:pic>
+        <p:nvPicPr>
+          <p:cNvPr id="3" name="Picture 2" descr="mark-4th-180.png"/>
+          <p:cNvPicPr>
+            <a:picLocks noChangeAspect="1"/>
+          </p:cNvPicPr>
           <p:nvPr/>
-        </p:nvSpPr>
-        <p:spPr>
-          <a:xfrm>
-            <a:off x="457200" y="548640"/>
-            <a:ext cx="640080" cy="640080"/>
-          </a:xfrm>
-          <a:prstGeom prst="rect">
-            <a:avLst/>
-          </a:prstGeom>
-          <a:solidFill>
-            <a:srgbClr val="2F7A5D"/>
-          </a:solidFill>
-          <a:ln>
-            <a:noFill/>
-          </a:ln>
-        </p:spPr>
-        <p:style>
-          <a:lnRef idx="1">
-            <a:schemeClr val="accent1"/>
-          </a:lnRef>
-          <a:fillRef idx="3">
-            <a:schemeClr val="accent1"/>
-          </a:fillRef>
-          <a:effectRef idx="2">
-            <a:schemeClr val="accent1"/>
-          </a:effectRef>
-          <a:fontRef idx="minor">
-            <a:schemeClr val="lt1"/>
-          </a:fontRef>
-        </p:style>
-        <p:txBody>
-          <a:bodyPr rtlCol="0" anchor="ctr"/>
-          <a:lstStyle/>
-          <a:p>
-            <a:pPr>
-              <a:defRPr>
-                <a:latin typeface="Roboto"/>
-              </a:defRPr>
-            </a:pPr>
-            <a:r>
-              <a:rPr sz="1600" b="1">
-                <a:solidFill>
-                  <a:srgbClr val="FFFFFF"/>
-                </a:solidFill>
-                <a:latin typeface="Roboto"/>
-              </a:rPr>
-              <a:t>4th</a:t>
-            </a:r>
-          </a:p>
-        </p:txBody>
-      </p:sp>
+        </p:nvPicPr>
+        <p:blipFill>
+          <a:blip r:embed="rId2"/>
+          <a:stretch>
+            <a:fillRect/>
+          </a:stretch>
+        </p:blipFill>
+        <p:spPr>
+          <a:xfrm>
+            <a:off x="365760" y="457200"/>
+            <a:ext cx="822960" cy="822960"/>
+          </a:xfrm>
+          <a:prstGeom prst="rect">
+            <a:avLst/>
+          </a:prstGeom>
+        </p:spPr>
+      </p:pic>
       <p:sp>
         <p:nvSpPr>
           <p:cNvPr id="4" name="TextBox 3"/>
@@ -4343,7 +4311,7 @@
                 </a:solidFill>
                 <a:latin typeface="Roboto"/>
               </a:rPr>
-              <a:t>Data retrieved 2pm, Tue 6 Oct 2026 · Generated 22 Oct 2026, 7:51pm · Sample data · Made with Python (python-pptx)</a:t>
+              <a:t>Data retrieved 2pm, Tue 6 Oct 2026 · Generated 28 Oct 2026, 12:45pm · Sample data · Made with Python (python-pptx)</a:t>
             </a:r>
           </a:p>
         </p:txBody>
@@ -5431,7 +5399,7 @@
                 </a:solidFill>
                 <a:latin typeface="Roboto"/>
               </a:rPr>
-              <a:t>Data retrieved 2pm, Tue 6 Oct 2026 · Generated 22 Oct 2026, 7:51pm · Sample data · Made with Python (python-pptx)</a:t>
+              <a:t>Data retrieved 2pm, Tue 6 Oct 2026 · Generated 28 Oct 2026, 12:45pm · Sample data · Made with Python (python-pptx)</a:t>
             </a:r>
           </a:p>
         </p:txBody>
@@ -5752,7 +5720,7 @@
                 </a:solidFill>
                 <a:latin typeface="Roboto"/>
               </a:rPr>
-              <a:t>Data retrieved 2pm, Tue 6 Oct 2026 · Generated 22 Oct 2026, 7:51pm · Sample data · Made with Python (python-pptx)</a:t>
+              <a:t>Data retrieved 2pm, Tue 6 Oct 2026 · Generated 28 Oct 2026, 12:45pm · Sample data · Made with Python (python-pptx)</a:t>
             </a:r>
           </a:p>
         </p:txBody>
@@ -6469,7 +6437,7 @@
                 </a:solidFill>
                 <a:latin typeface="Roboto"/>
               </a:rPr>
-              <a:t>Data retrieved 2pm, Tue 6 Oct 2026 · Generated 22 Oct 2026, 7:51pm · Sample data · Made with Python (python-pptx)</a:t>
+              <a:t>Data retrieved 2pm, Tue 6 Oct 2026 · Generated 28 Oct 2026, 12:45pm · Sample data · Made with Python (python-pptx)</a:t>
             </a:r>
           </a:p>
         </p:txBody>
@@ -7557,7 +7525,7 @@
                 </a:solidFill>
                 <a:latin typeface="Roboto"/>
               </a:rPr>
-              <a:t>Data retrieved 2pm, Tue 6 Oct 2026 · Generated 22 Oct 2026, 7:51pm · Sample data · Made with Python (python-pptx)</a:t>
+              <a:t>Data retrieved 2pm, Tue 6 Oct 2026 · Generated 28 Oct 2026, 12:45pm · Sample data · Made with Python (python-pptx)</a:t>
             </a:r>
           </a:p>
         </p:txBody>
@@ -7878,7 +7846,7 @@
                 </a:solidFill>
                 <a:latin typeface="Roboto"/>
               </a:rPr>
-              <a:t>Data retrieved 2pm, Tue 6 Oct 2026 · Generated 22 Oct 2026, 7:51pm · Sample data · Made with Python (python-pptx)</a:t>
+              <a:t>Data retrieved 2pm, Tue 6 Oct 2026 · Generated 28 Oct 2026, 12:45pm · Sample data · Made with Python (python-pptx)</a:t>
             </a:r>
           </a:p>
         </p:txBody>
@@ -8595,7 +8563,7 @@
                 </a:solidFill>
                 <a:latin typeface="Roboto"/>
               </a:rPr>
-              <a:t>Data retrieved 2pm, Tue 6 Oct 2026 · Generated 22 Oct 2026, 7:51pm · Sample data · Made with Python (python-pptx)</a:t>
+              <a:t>Data retrieved 2pm, Tue 6 Oct 2026 · Generated 28 Oct 2026, 12:45pm · Sample data · Made with Python (python-pptx)</a:t>
             </a:r>
           </a:p>
         </p:txBody>

</xml_diff>